<commit_message>
Fill the deck's team slide
Last slide still carried the template's own instructions to the author, on a
deck linked from the top of the README. Named, and the placeholder text is
gone from all five slides.

Co-Authored-By: Claude Opus 5 <noreply@anthropic.com>
</commit_message>
<xml_diff>
--- a/Documentation/RiverAir-Pitch-Deck.pptx
+++ b/Documentation/RiverAir-Pitch-Deck.pptx
@@ -8573,12 +8573,12 @@
                 <a:spcPts val="0"/>
               </a:spcBef>
               <a:spcAft>
-                <a:spcPts val="0"/>
+                <a:spcPts val="1000"/>
               </a:spcAft>
               <a:buNone/>
             </a:pPr>
             <a:r>
-              <a:rPr lang="en" sz="1500">
+              <a:rPr lang="en" sz="1800">
                 <a:solidFill>
                   <a:srgbClr val="F7E4B0"/>
                 </a:solidFill>
@@ -8587,9 +8587,9 @@
                 <a:cs typeface="Georgia"/>
                 <a:sym typeface="Georgia"/>
               </a:rPr>
-              <a:t>Finally, explain who is behind the project.</a:t>
+              <a:t>Hasan Kaşıkcı — solo build</a:t>
             </a:r>
-            <a:endParaRPr sz="1500">
+            <a:endParaRPr sz="1800">
               <a:solidFill>
                 <a:srgbClr val="F7E4B0"/>
               </a:solidFill>
@@ -8608,43 +8608,12 @@
                 <a:spcPts val="0"/>
               </a:spcBef>
               <a:spcAft>
-                <a:spcPts val="0"/>
+                <a:spcPts val="1000"/>
               </a:spcAft>
               <a:buNone/>
             </a:pPr>
             <a:r>
-              <a:t/>
-            </a:r>
-            <a:endParaRPr sz="1500">
-              <a:solidFill>
-                <a:srgbClr val="F7E4B0"/>
-              </a:solidFill>
-              <a:latin typeface="Georgia"/>
-              <a:ea typeface="Georgia"/>
-              <a:cs typeface="Georgia"/>
-              <a:sym typeface="Georgia"/>
-            </a:endParaRPr>
-          </a:p>
-          <a:p>
-            <a:pPr indent="-323850" lvl="0" marL="457200" rtl="0" algn="l">
-              <a:lnSpc>
-                <a:spcPct val="132000"/>
-              </a:lnSpc>
-              <a:spcBef>
-                <a:spcPts val="0"/>
-              </a:spcBef>
-              <a:spcAft>
-                <a:spcPts val="0"/>
-              </a:spcAft>
-              <a:buClr>
-                <a:srgbClr val="F7E4B0"/>
-              </a:buClr>
-              <a:buSzPts val="1500"/>
-              <a:buFont typeface="Georgia"/>
-              <a:buChar char="●"/>
-            </a:pPr>
-            <a:r>
-              <a:rPr lang="en" sz="1500">
+              <a:rPr lang="en" sz="1800">
                 <a:solidFill>
                   <a:srgbClr val="F7E4B0"/>
                 </a:solidFill>
@@ -8653,89 +8622,9 @@
                 <a:cs typeface="Georgia"/>
                 <a:sym typeface="Georgia"/>
               </a:rPr>
-              <a:t>Highlight the skills and roles of your team members.</a:t>
+              <a:t>Soroban escrow contract, the anchor integration over SEP-1/6/10/12/38, the wallet layer and the payment flow end to end.</a:t>
             </a:r>
-            <a:endParaRPr sz="1500">
-              <a:solidFill>
-                <a:srgbClr val="F7E4B0"/>
-              </a:solidFill>
-              <a:latin typeface="Georgia"/>
-              <a:ea typeface="Georgia"/>
-              <a:cs typeface="Georgia"/>
-              <a:sym typeface="Georgia"/>
-            </a:endParaRPr>
-          </a:p>
-          <a:p>
-            <a:pPr indent="-323850" lvl="0" marL="457200" rtl="0" algn="l">
-              <a:lnSpc>
-                <a:spcPct val="132000"/>
-              </a:lnSpc>
-              <a:spcBef>
-                <a:spcPts val="0"/>
-              </a:spcBef>
-              <a:spcAft>
-                <a:spcPts val="0"/>
-              </a:spcAft>
-              <a:buClr>
-                <a:srgbClr val="F7E4B0"/>
-              </a:buClr>
-              <a:buSzPts val="1500"/>
-              <a:buFont typeface="Georgia"/>
-              <a:buChar char="●"/>
-            </a:pPr>
-            <a:r>
-              <a:rPr lang="en" sz="1500">
-                <a:solidFill>
-                  <a:srgbClr val="F7E4B0"/>
-                </a:solidFill>
-                <a:latin typeface="Georgia"/>
-                <a:ea typeface="Georgia"/>
-                <a:cs typeface="Georgia"/>
-                <a:sym typeface="Georgia"/>
-              </a:rPr>
-              <a:t>Add a small picture of the team.</a:t>
-            </a:r>
-            <a:endParaRPr sz="1500">
-              <a:solidFill>
-                <a:srgbClr val="F7E4B0"/>
-              </a:solidFill>
-              <a:latin typeface="Georgia"/>
-              <a:ea typeface="Georgia"/>
-              <a:cs typeface="Georgia"/>
-              <a:sym typeface="Georgia"/>
-            </a:endParaRPr>
-          </a:p>
-          <a:p>
-            <a:pPr indent="-323850" lvl="0" marL="457200" rtl="0" algn="l">
-              <a:lnSpc>
-                <a:spcPct val="132000"/>
-              </a:lnSpc>
-              <a:spcBef>
-                <a:spcPts val="0"/>
-              </a:spcBef>
-              <a:spcAft>
-                <a:spcPts val="0"/>
-              </a:spcAft>
-              <a:buClr>
-                <a:srgbClr val="F7E4B0"/>
-              </a:buClr>
-              <a:buSzPts val="1500"/>
-              <a:buFont typeface="Georgia"/>
-              <a:buChar char="●"/>
-            </a:pPr>
-            <a:r>
-              <a:rPr lang="en" sz="1500">
-                <a:solidFill>
-                  <a:srgbClr val="F7E4B0"/>
-                </a:solidFill>
-                <a:latin typeface="Georgia"/>
-                <a:ea typeface="Georgia"/>
-                <a:cs typeface="Georgia"/>
-                <a:sym typeface="Georgia"/>
-              </a:rPr>
-              <a:t>Use a maximum of 3 lines for each member.</a:t>
-            </a:r>
-            <a:endParaRPr sz="1500">
+            <a:endParaRPr sz="1800">
               <a:solidFill>
                 <a:srgbClr val="F7E4B0"/>
               </a:solidFill>
@@ -8754,193 +8643,23 @@
                 <a:spcPts val="0"/>
               </a:spcBef>
               <a:spcAft>
-                <a:spcPts val="0"/>
+                <a:spcPts val="1000"/>
               </a:spcAft>
               <a:buNone/>
             </a:pPr>
             <a:r>
-              <a:t/>
+              <a:rPr lang="en" sz="1800">
+                <a:solidFill>
+                  <a:srgbClr val="F7E4B0"/>
+                </a:solidFill>
+                <a:latin typeface="Georgia"/>
+                <a:ea typeface="Georgia"/>
+                <a:cs typeface="Georgia"/>
+                <a:sym typeface="Georgia"/>
+              </a:rPr>
+              <a:t>The agentic fleet simulation, the operational interface, and the hardware node blueprint the edge is shaped around.</a:t>
             </a:r>
-            <a:endParaRPr sz="1500">
-              <a:solidFill>
-                <a:srgbClr val="F7E4B0"/>
-              </a:solidFill>
-              <a:latin typeface="Georgia"/>
-              <a:ea typeface="Georgia"/>
-              <a:cs typeface="Georgia"/>
-              <a:sym typeface="Georgia"/>
-            </a:endParaRPr>
-          </a:p>
-          <a:p>
-            <a:pPr indent="0" lvl="0" marL="0" rtl="0" algn="l">
-              <a:lnSpc>
-                <a:spcPct val="132000"/>
-              </a:lnSpc>
-              <a:spcBef>
-                <a:spcPts val="0"/>
-              </a:spcBef>
-              <a:spcAft>
-                <a:spcPts val="0"/>
-              </a:spcAft>
-              <a:buNone/>
-            </a:pPr>
-            <a:r>
-              <a:t/>
-            </a:r>
-            <a:endParaRPr sz="1500">
-              <a:solidFill>
-                <a:srgbClr val="F7E4B0"/>
-              </a:solidFill>
-              <a:latin typeface="Georgia"/>
-              <a:ea typeface="Georgia"/>
-              <a:cs typeface="Georgia"/>
-              <a:sym typeface="Georgia"/>
-            </a:endParaRPr>
-          </a:p>
-          <a:p>
-            <a:pPr indent="0" lvl="0" marL="0" rtl="0" algn="l">
-              <a:lnSpc>
-                <a:spcPct val="116666"/>
-              </a:lnSpc>
-              <a:spcBef>
-                <a:spcPts val="0"/>
-              </a:spcBef>
-              <a:spcAft>
-                <a:spcPts val="0"/>
-              </a:spcAft>
-              <a:buNone/>
-            </a:pPr>
-            <a:r>
-              <a:t/>
-            </a:r>
-            <a:endParaRPr sz="1500">
-              <a:solidFill>
-                <a:srgbClr val="F7E4B0"/>
-              </a:solidFill>
-              <a:latin typeface="Georgia"/>
-              <a:ea typeface="Georgia"/>
-              <a:cs typeface="Georgia"/>
-              <a:sym typeface="Georgia"/>
-            </a:endParaRPr>
-          </a:p>
-          <a:p>
-            <a:pPr indent="0" lvl="0" marL="0" rtl="0" algn="l">
-              <a:lnSpc>
-                <a:spcPct val="132000"/>
-              </a:lnSpc>
-              <a:spcBef>
-                <a:spcPts val="0"/>
-              </a:spcBef>
-              <a:spcAft>
-                <a:spcPts val="0"/>
-              </a:spcAft>
-              <a:buNone/>
-            </a:pPr>
-            <a:r>
-              <a:t/>
-            </a:r>
-            <a:endParaRPr sz="1500">
-              <a:solidFill>
-                <a:srgbClr val="F7E4B0"/>
-              </a:solidFill>
-              <a:latin typeface="Georgia"/>
-              <a:ea typeface="Georgia"/>
-              <a:cs typeface="Georgia"/>
-              <a:sym typeface="Georgia"/>
-            </a:endParaRPr>
-          </a:p>
-          <a:p>
-            <a:pPr indent="0" lvl="0" marL="0" rtl="0" algn="l">
-              <a:lnSpc>
-                <a:spcPct val="132000"/>
-              </a:lnSpc>
-              <a:spcBef>
-                <a:spcPts val="0"/>
-              </a:spcBef>
-              <a:spcAft>
-                <a:spcPts val="0"/>
-              </a:spcAft>
-              <a:buNone/>
-            </a:pPr>
-            <a:r>
-              <a:t/>
-            </a:r>
-            <a:endParaRPr i="1" sz="1500">
-              <a:solidFill>
-                <a:srgbClr val="F7E4B0"/>
-              </a:solidFill>
-              <a:latin typeface="Georgia"/>
-              <a:ea typeface="Georgia"/>
-              <a:cs typeface="Georgia"/>
-              <a:sym typeface="Georgia"/>
-            </a:endParaRPr>
-          </a:p>
-          <a:p>
-            <a:pPr indent="0" lvl="0" marL="0" rtl="0" algn="l">
-              <a:lnSpc>
-                <a:spcPct val="140000"/>
-              </a:lnSpc>
-              <a:spcBef>
-                <a:spcPts val="0"/>
-              </a:spcBef>
-              <a:spcAft>
-                <a:spcPts val="0"/>
-              </a:spcAft>
-              <a:buNone/>
-            </a:pPr>
-            <a:r>
-              <a:t/>
-            </a:r>
-            <a:endParaRPr i="1" sz="1500">
-              <a:solidFill>
-                <a:srgbClr val="F7E4B0"/>
-              </a:solidFill>
-              <a:latin typeface="Georgia"/>
-              <a:ea typeface="Georgia"/>
-              <a:cs typeface="Georgia"/>
-              <a:sym typeface="Georgia"/>
-            </a:endParaRPr>
-          </a:p>
-          <a:p>
-            <a:pPr indent="0" lvl="0" marL="0" rtl="0" algn="l">
-              <a:lnSpc>
-                <a:spcPct val="116666"/>
-              </a:lnSpc>
-              <a:spcBef>
-                <a:spcPts val="0"/>
-              </a:spcBef>
-              <a:spcAft>
-                <a:spcPts val="0"/>
-              </a:spcAft>
-              <a:buNone/>
-            </a:pPr>
-            <a:r>
-              <a:t/>
-            </a:r>
-            <a:endParaRPr sz="1500">
-              <a:solidFill>
-                <a:srgbClr val="F7E4B0"/>
-              </a:solidFill>
-              <a:latin typeface="Georgia"/>
-              <a:ea typeface="Georgia"/>
-              <a:cs typeface="Georgia"/>
-              <a:sym typeface="Georgia"/>
-            </a:endParaRPr>
-          </a:p>
-          <a:p>
-            <a:pPr indent="0" lvl="0" marL="0" rtl="0" algn="l">
-              <a:spcBef>
-                <a:spcPts val="0"/>
-              </a:spcBef>
-              <a:spcAft>
-                <a:spcPts val="0"/>
-              </a:spcAft>
-              <a:buNone/>
-            </a:pPr>
-            <a:r>
-              <a:t/>
-            </a:r>
-            <a:endParaRPr sz="1500">
+            <a:endParaRPr sz="1800">
               <a:solidFill>
                 <a:srgbClr val="F7E4B0"/>
               </a:solidFill>

</xml_diff>